<commit_message>
Updates after first lecture
</commit_message>
<xml_diff>
--- a/Lecture slides/NYT A01 - Introduction.pptx
+++ b/Lecture slides/NYT A01 - Introduction.pptx
@@ -32,7 +32,6 @@
     <p:sldId id="277" r:id="rId27"/>
     <p:sldId id="278" r:id="rId28"/>
     <p:sldId id="279" r:id="rId29"/>
-    <p:sldId id="280" r:id="rId30"/>
   </p:sldIdLst>
   <p:sldSz cy="5143500" cx="9144000"/>
   <p:notesSz cx="6858000" cy="9144000"/>
@@ -1109,7 +1108,7 @@
       </p:grpSpPr>
       <p:sp>
         <p:nvSpPr>
-          <p:cNvPr id="121" name="Google Shape;121;g108fe332759_2_149:notes"/>
+          <p:cNvPr id="121" name="Google Shape;121;g350a653ad53_0_0:notes"/>
           <p:cNvSpPr/>
           <p:nvPr>
             <p:ph idx="2" type="sldImg"/>
@@ -1144,7 +1143,7 @@
       </p:sp>
       <p:sp>
         <p:nvSpPr>
-          <p:cNvPr id="122" name="Google Shape;122;g108fe332759_2_149:notes"/>
+          <p:cNvPr id="122" name="Google Shape;122;g350a653ad53_0_0:notes"/>
           <p:cNvSpPr txBox="1"/>
           <p:nvPr>
             <p:ph idx="1" type="body"/>
@@ -1208,7 +1207,7 @@
       </p:grpSpPr>
       <p:sp>
         <p:nvSpPr>
-          <p:cNvPr id="128" name="Google Shape;128;g108fe332759_2_133:notes"/>
+          <p:cNvPr id="128" name="Google Shape;128;g108fe332759_2_149:notes"/>
           <p:cNvSpPr/>
           <p:nvPr>
             <p:ph idx="2" type="sldImg"/>
@@ -1243,7 +1242,7 @@
       </p:sp>
       <p:sp>
         <p:nvSpPr>
-          <p:cNvPr id="129" name="Google Shape;129;g108fe332759_2_133:notes"/>
+          <p:cNvPr id="129" name="Google Shape;129;g108fe332759_2_149:notes"/>
           <p:cNvSpPr txBox="1"/>
           <p:nvPr>
             <p:ph idx="1" type="body"/>
@@ -2198,7 +2197,7 @@
       </p:grpSpPr>
       <p:sp>
         <p:nvSpPr>
-          <p:cNvPr id="194" name="Google Shape;194;g108fe332759_2_55:notes"/>
+          <p:cNvPr id="194" name="Google Shape;194;g2395919313b_0_38:notes"/>
           <p:cNvSpPr/>
           <p:nvPr>
             <p:ph idx="2" type="sldImg"/>
@@ -2233,7 +2232,7 @@
       </p:sp>
       <p:sp>
         <p:nvSpPr>
-          <p:cNvPr id="195" name="Google Shape;195;g108fe332759_2_55:notes"/>
+          <p:cNvPr id="195" name="Google Shape;195;g2395919313b_0_38:notes"/>
           <p:cNvSpPr txBox="1"/>
           <p:nvPr>
             <p:ph idx="1" type="body"/>
@@ -2283,7 +2282,7 @@
   <p:cSld>
     <p:spTree>
       <p:nvGrpSpPr>
-        <p:cNvPr id="200" name="Shape 200"/>
+        <p:cNvPr id="199" name="Shape 199"/>
         <p:cNvGrpSpPr/>
         <p:nvPr/>
       </p:nvGrpSpPr>
@@ -2297,7 +2296,7 @@
       </p:grpSpPr>
       <p:sp>
         <p:nvSpPr>
-          <p:cNvPr id="201" name="Google Shape;201;g2395919313b_0_38:notes"/>
+          <p:cNvPr id="200" name="Google Shape;200;g2395919313b_0_43:notes"/>
           <p:cNvSpPr/>
           <p:nvPr>
             <p:ph idx="2" type="sldImg"/>
@@ -2332,106 +2331,7 @@
       </p:sp>
       <p:sp>
         <p:nvSpPr>
-          <p:cNvPr id="202" name="Google Shape;202;g2395919313b_0_38:notes"/>
-          <p:cNvSpPr txBox="1"/>
-          <p:nvPr>
-            <p:ph idx="1" type="body"/>
-          </p:nvPr>
-        </p:nvSpPr>
-        <p:spPr>
-          <a:xfrm>
-            <a:off x="685800" y="4343400"/>
-            <a:ext cx="5486400" cy="4114800"/>
-          </a:xfrm>
-          <a:prstGeom prst="rect">
-            <a:avLst/>
-          </a:prstGeom>
-        </p:spPr>
-        <p:txBody>
-          <a:bodyPr anchorCtr="0" anchor="t" bIns="91425" lIns="91425" spcFirstLastPara="1" rIns="91425" wrap="square" tIns="91425">
-            <a:noAutofit/>
-          </a:bodyPr>
-          <a:lstStyle/>
-          <a:p>
-            <a:pPr indent="0" lvl="0" marL="0" rtl="0" algn="l">
-              <a:spcBef>
-                <a:spcPts val="0"/>
-              </a:spcBef>
-              <a:spcAft>
-                <a:spcPts val="0"/>
-              </a:spcAft>
-              <a:buNone/>
-            </a:pPr>
-            <a:r>
-              <a:t/>
-            </a:r>
-            <a:endParaRPr/>
-          </a:p>
-        </p:txBody>
-      </p:sp>
-    </p:spTree>
-  </p:cSld>
-  <p:clrMapOvr>
-    <a:masterClrMapping/>
-  </p:clrMapOvr>
-</p:notes>
-</file>
-
-<file path=ppt/notesSlides/notesSlide25.xml><?xml version="1.0" encoding="utf-8"?>
-<p:notes xmlns:a="http://schemas.openxmlformats.org/drawingml/2006/main" xmlns:r="http://schemas.openxmlformats.org/officeDocument/2006/relationships" xmlns:mc="http://schemas.openxmlformats.org/markup-compatibility/2006" xmlns:mv="urn:schemas-microsoft-com:mac:vml" xmlns:p="http://schemas.openxmlformats.org/presentationml/2006/main" xmlns:c="http://schemas.openxmlformats.org/drawingml/2006/chart" xmlns:dgm="http://schemas.openxmlformats.org/drawingml/2006/diagram" xmlns:o="urn:schemas-microsoft-com:office:office" xmlns:v="urn:schemas-microsoft-com:vml" xmlns:pvml="urn:schemas-microsoft-com:office:powerpoint" xmlns:com="http://schemas.openxmlformats.org/drawingml/2006/compatibility" xmlns:p14="http://schemas.microsoft.com/office/powerpoint/2010/main" xmlns:p15="http://schemas.microsoft.com/office/powerpoint/2012/main" xmlns:ahyp="http://schemas.microsoft.com/office/drawing/2018/hyperlinkcolor" showMasterPhAnim="0" showMasterSp="0">
-  <p:cSld>
-    <p:spTree>
-      <p:nvGrpSpPr>
-        <p:cNvPr id="206" name="Shape 206"/>
-        <p:cNvGrpSpPr/>
-        <p:nvPr/>
-      </p:nvGrpSpPr>
-      <p:grpSpPr>
-        <a:xfrm>
-          <a:off x="0" y="0"/>
-          <a:ext cx="0" cy="0"/>
-          <a:chOff x="0" y="0"/>
-          <a:chExt cx="0" cy="0"/>
-        </a:xfrm>
-      </p:grpSpPr>
-      <p:sp>
-        <p:nvSpPr>
-          <p:cNvPr id="207" name="Google Shape;207;g2395919313b_0_43:notes"/>
-          <p:cNvSpPr/>
-          <p:nvPr>
-            <p:ph idx="2" type="sldImg"/>
-          </p:nvPr>
-        </p:nvSpPr>
-        <p:spPr>
-          <a:xfrm>
-            <a:off x="381300" y="685800"/>
-            <a:ext cx="6096000" cy="3429000"/>
-          </a:xfrm>
-          <a:custGeom>
-            <a:rect b="b" l="l" r="r" t="t"/>
-            <a:pathLst>
-              <a:path extrusionOk="0" h="120000" w="120000">
-                <a:moveTo>
-                  <a:pt x="0" y="0"/>
-                </a:moveTo>
-                <a:lnTo>
-                  <a:pt x="120000" y="0"/>
-                </a:lnTo>
-                <a:lnTo>
-                  <a:pt x="120000" y="120000"/>
-                </a:lnTo>
-                <a:lnTo>
-                  <a:pt x="0" y="120000"/>
-                </a:lnTo>
-                <a:close/>
-              </a:path>
-            </a:pathLst>
-          </a:custGeom>
-        </p:spPr>
-      </p:sp>
-      <p:sp>
-        <p:nvSpPr>
-          <p:cNvPr id="208" name="Google Shape;208;g2395919313b_0_43:notes"/>
+          <p:cNvPr id="201" name="Google Shape;201;g2395919313b_0_43:notes"/>
           <p:cNvSpPr txBox="1"/>
           <p:nvPr>
             <p:ph idx="1" type="body"/>
@@ -6637,7 +6537,7 @@
             </a:pPr>
             <a:r>
               <a:rPr lang="en"/>
-              <a:t>Dirk Riehle, Univ. Erlangen</a:t>
+              <a:t>Dirk Riehle, FAU Erlangen</a:t>
             </a:r>
             <a:endParaRPr/>
           </a:p>
@@ -6907,6 +6807,23 @@
             <a:endParaRPr/>
           </a:p>
           <a:p>
+            <a:pPr indent="-317500" lvl="1" marL="914400" rtl="0" algn="l">
+              <a:spcBef>
+                <a:spcPts val="0"/>
+              </a:spcBef>
+              <a:spcAft>
+                <a:spcPts val="0"/>
+              </a:spcAft>
+              <a:buSzPts val="1400"/>
+              <a:buChar char="○"/>
+            </a:pPr>
+            <a:r>
+              <a:rPr lang="en"/>
+              <a:t>Miss more than three quizzes and you fail the class</a:t>
+            </a:r>
+            <a:endParaRPr/>
+          </a:p>
+          <a:p>
             <a:pPr indent="-342900" lvl="0" marL="457200" rtl="0" algn="l">
               <a:spcBef>
                 <a:spcPts val="1000"/>
@@ -6937,6 +6854,23 @@
             <a:r>
               <a:rPr lang="en"/>
               <a:t>Graded using [0..10] using tool and grading rubric</a:t>
+            </a:r>
+            <a:endParaRPr/>
+          </a:p>
+          <a:p>
+            <a:pPr indent="-317500" lvl="1" marL="914400" rtl="0" algn="l">
+              <a:spcBef>
+                <a:spcPts val="0"/>
+              </a:spcBef>
+              <a:spcAft>
+                <a:spcPts val="0"/>
+              </a:spcAft>
+              <a:buSzPts val="1400"/>
+              <a:buChar char="○"/>
+            </a:pPr>
+            <a:r>
+              <a:rPr lang="en"/>
+              <a:t>Miss more than one exercise and you fail the class</a:t>
             </a:r>
             <a:endParaRPr/>
           </a:p>
@@ -6979,19 +6913,19 @@
             <a:endParaRPr/>
           </a:p>
           <a:p>
-            <a:pPr indent="-317500" lvl="1" marL="914400" rtl="0" algn="l">
-              <a:spcBef>
-                <a:spcPts val="0"/>
-              </a:spcBef>
-              <a:spcAft>
-                <a:spcPts val="0"/>
-              </a:spcAft>
-              <a:buSzPts val="1400"/>
-              <a:buChar char="○"/>
+            <a:pPr indent="-342900" lvl="0" marL="457200" rtl="0" algn="l">
+              <a:spcBef>
+                <a:spcPts val="0"/>
+              </a:spcBef>
+              <a:spcAft>
+                <a:spcPts val="0"/>
+              </a:spcAft>
+              <a:buSzPts val="1800"/>
+              <a:buChar char="●"/>
             </a:pPr>
             <a:r>
               <a:rPr lang="en"/>
-              <a:t>If you insist on an oral exam, please tell us within two weeks after the last session</a:t>
+              <a:t>Oral exam is scheduled during class on the last class day</a:t>
             </a:r>
             <a:endParaRPr/>
           </a:p>
@@ -7628,7 +7562,7 @@
           </a:prstGeom>
         </p:spPr>
         <p:txBody>
-          <a:bodyPr anchorCtr="0" anchor="ctr" bIns="0" lIns="274300" spcFirstLastPara="1" rIns="0" wrap="square" tIns="0">
+          <a:bodyPr anchorCtr="0" anchor="ctr" bIns="91425" lIns="274300" spcFirstLastPara="1" rIns="91425" wrap="square" tIns="91425">
             <a:noAutofit/>
           </a:bodyPr>
           <a:lstStyle/>
@@ -7644,7 +7578,7 @@
             </a:pPr>
             <a:r>
               <a:rPr lang="en"/>
-              <a:t>Grading Rubric for Homework Submissions</a:t>
+              <a:t>Grading Rules</a:t>
             </a:r>
             <a:endParaRPr/>
           </a:p>
@@ -7653,6 +7587,77 @@
       <p:sp>
         <p:nvSpPr>
           <p:cNvPr id="125" name="Google Shape;125;p20"/>
+          <p:cNvSpPr txBox="1"/>
+          <p:nvPr>
+            <p:ph idx="1" type="body"/>
+          </p:nvPr>
+        </p:nvSpPr>
+        <p:spPr>
+          <a:xfrm>
+            <a:off x="274320" y="914400"/>
+            <a:ext cx="8595300" cy="4114800"/>
+          </a:xfrm>
+          <a:prstGeom prst="rect">
+            <a:avLst/>
+          </a:prstGeom>
+        </p:spPr>
+        <p:txBody>
+          <a:bodyPr anchorCtr="0" anchor="t" bIns="0" lIns="0" spcFirstLastPara="1" rIns="0" wrap="square" tIns="0">
+            <a:noAutofit/>
+          </a:bodyPr>
+          <a:lstStyle/>
+          <a:p>
+            <a:pPr indent="0" lvl="0" marL="0" rtl="0" algn="l">
+              <a:spcBef>
+                <a:spcPts val="0"/>
+              </a:spcBef>
+              <a:spcAft>
+                <a:spcPts val="0"/>
+              </a:spcAft>
+              <a:buNone/>
+            </a:pPr>
+            <a:r>
+              <a:rPr lang="en"/>
+              <a:t>All homework is individual work</a:t>
+            </a:r>
+            <a:endParaRPr/>
+          </a:p>
+          <a:p>
+            <a:pPr indent="0" lvl="0" marL="0" rtl="0" algn="l">
+              <a:spcBef>
+                <a:spcPts val="1200"/>
+              </a:spcBef>
+              <a:spcAft>
+                <a:spcPts val="0"/>
+              </a:spcAft>
+              <a:buNone/>
+            </a:pPr>
+            <a:r>
+              <a:rPr lang="en"/>
+              <a:t>No AIs allowed during exams</a:t>
+            </a:r>
+            <a:endParaRPr/>
+          </a:p>
+          <a:p>
+            <a:pPr indent="0" lvl="0" marL="0" rtl="0" algn="l">
+              <a:spcBef>
+                <a:spcPts val="1200"/>
+              </a:spcBef>
+              <a:spcAft>
+                <a:spcPts val="1200"/>
+              </a:spcAft>
+              <a:buNone/>
+            </a:pPr>
+            <a:r>
+              <a:t/>
+            </a:r>
+            <a:endParaRPr/>
+          </a:p>
+        </p:txBody>
+      </p:sp>
+      <p:sp>
+        <p:nvSpPr>
+          <p:cNvPr id="126" name="Google Shape;126;p20"/>
           <p:cNvSpPr txBox="1"/>
           <p:nvPr>
             <p:ph idx="12" type="sldNum"/>
@@ -7715,9 +7720,139 @@
           </a:p>
         </p:txBody>
       </p:sp>
+    </p:spTree>
+  </p:cSld>
+  <p:clrMapOvr>
+    <a:masterClrMapping/>
+  </p:clrMapOvr>
+</p:sld>
+</file>
+
+<file path=ppt/slides/slide14.xml><?xml version="1.0" encoding="utf-8"?>
+<p:sld xmlns:a="http://schemas.openxmlformats.org/drawingml/2006/main" xmlns:r="http://schemas.openxmlformats.org/officeDocument/2006/relationships" xmlns:mc="http://schemas.openxmlformats.org/markup-compatibility/2006" xmlns:mv="urn:schemas-microsoft-com:mac:vml" xmlns:p="http://schemas.openxmlformats.org/presentationml/2006/main" xmlns:c="http://schemas.openxmlformats.org/drawingml/2006/chart" xmlns:dgm="http://schemas.openxmlformats.org/drawingml/2006/diagram" xmlns:o="urn:schemas-microsoft-com:office:office" xmlns:v="urn:schemas-microsoft-com:vml" xmlns:pvml="urn:schemas-microsoft-com:office:powerpoint" xmlns:com="http://schemas.openxmlformats.org/drawingml/2006/compatibility" xmlns:p14="http://schemas.microsoft.com/office/powerpoint/2010/main" xmlns:p15="http://schemas.microsoft.com/office/powerpoint/2012/main" xmlns:ahyp="http://schemas.microsoft.com/office/drawing/2018/hyperlinkcolor" show="0">
+  <p:cSld>
+    <p:spTree>
+      <p:nvGrpSpPr>
+        <p:cNvPr id="130" name="Shape 130"/>
+        <p:cNvGrpSpPr/>
+        <p:nvPr/>
+      </p:nvGrpSpPr>
+      <p:grpSpPr>
+        <a:xfrm>
+          <a:off x="0" y="0"/>
+          <a:ext cx="0" cy="0"/>
+          <a:chOff x="0" y="0"/>
+          <a:chExt cx="0" cy="0"/>
+        </a:xfrm>
+      </p:grpSpPr>
+      <p:sp>
+        <p:nvSpPr>
+          <p:cNvPr id="131" name="Google Shape;131;p21"/>
+          <p:cNvSpPr txBox="1"/>
+          <p:nvPr>
+            <p:ph type="title"/>
+          </p:nvPr>
+        </p:nvSpPr>
+        <p:spPr>
+          <a:xfrm>
+            <a:off x="0" y="0"/>
+            <a:ext cx="9144000" cy="685800"/>
+          </a:xfrm>
+          <a:prstGeom prst="rect">
+            <a:avLst/>
+          </a:prstGeom>
+        </p:spPr>
+        <p:txBody>
+          <a:bodyPr anchorCtr="0" anchor="ctr" bIns="0" lIns="274300" spcFirstLastPara="1" rIns="0" wrap="square" tIns="0">
+            <a:noAutofit/>
+          </a:bodyPr>
+          <a:lstStyle/>
+          <a:p>
+            <a:pPr indent="0" lvl="0" marL="0" rtl="0" algn="l">
+              <a:spcBef>
+                <a:spcPts val="0"/>
+              </a:spcBef>
+              <a:spcAft>
+                <a:spcPts val="0"/>
+              </a:spcAft>
+              <a:buNone/>
+            </a:pPr>
+            <a:r>
+              <a:rPr lang="en"/>
+              <a:t>Grading Rubric for Homework Submissions</a:t>
+            </a:r>
+            <a:endParaRPr/>
+          </a:p>
+        </p:txBody>
+      </p:sp>
+      <p:sp>
+        <p:nvSpPr>
+          <p:cNvPr id="132" name="Google Shape;132;p21"/>
+          <p:cNvSpPr txBox="1"/>
+          <p:nvPr>
+            <p:ph idx="12" type="sldNum"/>
+          </p:nvPr>
+        </p:nvSpPr>
+        <p:spPr>
+          <a:xfrm>
+            <a:off x="7315209" y="4229101"/>
+            <a:ext cx="1828800" cy="914400"/>
+          </a:xfrm>
+          <a:prstGeom prst="rect">
+            <a:avLst/>
+          </a:prstGeom>
+        </p:spPr>
+        <p:txBody>
+          <a:bodyPr anchorCtr="0" anchor="b" bIns="91425" lIns="91425" spcFirstLastPara="1" rIns="91425" wrap="square" tIns="91425">
+            <a:noAutofit/>
+          </a:bodyPr>
+          <a:lstStyle/>
+          <a:p>
+            <a:pPr indent="0" lvl="0" marL="0" rtl="0" algn="r">
+              <a:spcBef>
+                <a:spcPts val="0"/>
+              </a:spcBef>
+              <a:spcAft>
+                <a:spcPts val="0"/>
+              </a:spcAft>
+              <a:buNone/>
+            </a:pPr>
+            <a:fld id="{00000000-1234-1234-1234-123412341234}" type="slidenum">
+              <a:rPr lang="en"/>
+              <a:t>‹#›</a:t>
+            </a:fld>
+            <a:endParaRPr/>
+          </a:p>
+          <a:p>
+            <a:pPr indent="0" lvl="0" marL="0" rtl="0" algn="r">
+              <a:spcBef>
+                <a:spcPts val="0"/>
+              </a:spcBef>
+              <a:spcAft>
+                <a:spcPts val="0"/>
+              </a:spcAft>
+              <a:buNone/>
+            </a:pPr>
+            <a:r>
+              <a:rPr b="0" lang="en" sz="1000" u="sng">
+                <a:solidFill>
+                  <a:schemeClr val="hlink"/>
+                </a:solidFill>
+                <a:hlinkClick r:id="rId3"/>
+              </a:rPr>
+              <a:t>uni1.de/nyt</a:t>
+            </a:r>
+            <a:r>
+              <a:rPr b="0" lang="en" sz="1000"/>
+              <a:t> </a:t>
+            </a:r>
+            <a:endParaRPr b="0" sz="1000"/>
+          </a:p>
+        </p:txBody>
+      </p:sp>
       <p:graphicFrame>
         <p:nvGraphicFramePr>
-          <p:cNvPr id="126" name="Google Shape;126;p20"/>
+          <p:cNvPr id="133" name="Google Shape;133;p21"/>
           <p:cNvGraphicFramePr/>
           <p:nvPr/>
         </p:nvGraphicFramePr>
@@ -7730,7 +7865,7 @@
             <a:tbl>
               <a:tblPr>
                 <a:noFill/>
-                <a:tableStyleId>{BDD3B64A-7FFF-4E8F-87F6-037DE44E73C1}</a:tableStyleId>
+                <a:tableStyleId>{96A21E03-E013-4868-B2C2-C3E1341E02A3}</a:tableStyleId>
               </a:tblPr>
               <a:tblGrid>
                 <a:gridCol w="1227850"/>
@@ -9316,310 +9451,6 @@
 </p:sld>
 </file>
 
-<file path=ppt/slides/slide14.xml><?xml version="1.0" encoding="utf-8"?>
-<p:sld xmlns:a="http://schemas.openxmlformats.org/drawingml/2006/main" xmlns:r="http://schemas.openxmlformats.org/officeDocument/2006/relationships" xmlns:mc="http://schemas.openxmlformats.org/markup-compatibility/2006" xmlns:mv="urn:schemas-microsoft-com:mac:vml" xmlns:p="http://schemas.openxmlformats.org/presentationml/2006/main" xmlns:c="http://schemas.openxmlformats.org/drawingml/2006/chart" xmlns:dgm="http://schemas.openxmlformats.org/drawingml/2006/diagram" xmlns:o="urn:schemas-microsoft-com:office:office" xmlns:v="urn:schemas-microsoft-com:vml" xmlns:pvml="urn:schemas-microsoft-com:office:powerpoint" xmlns:com="http://schemas.openxmlformats.org/drawingml/2006/compatibility" xmlns:p14="http://schemas.microsoft.com/office/powerpoint/2010/main" xmlns:p15="http://schemas.microsoft.com/office/powerpoint/2012/main" xmlns:ahyp="http://schemas.microsoft.com/office/drawing/2018/hyperlinkcolor">
-  <p:cSld>
-    <p:spTree>
-      <p:nvGrpSpPr>
-        <p:cNvPr id="130" name="Shape 130"/>
-        <p:cNvGrpSpPr/>
-        <p:nvPr/>
-      </p:nvGrpSpPr>
-      <p:grpSpPr>
-        <a:xfrm>
-          <a:off x="0" y="0"/>
-          <a:ext cx="0" cy="0"/>
-          <a:chOff x="0" y="0"/>
-          <a:chExt cx="0" cy="0"/>
-        </a:xfrm>
-      </p:grpSpPr>
-      <p:sp>
-        <p:nvSpPr>
-          <p:cNvPr id="131" name="Google Shape;131;p21"/>
-          <p:cNvSpPr txBox="1"/>
-          <p:nvPr>
-            <p:ph type="title"/>
-          </p:nvPr>
-        </p:nvSpPr>
-        <p:spPr>
-          <a:xfrm>
-            <a:off x="0" y="0"/>
-            <a:ext cx="9144000" cy="685800"/>
-          </a:xfrm>
-          <a:prstGeom prst="rect">
-            <a:avLst/>
-          </a:prstGeom>
-        </p:spPr>
-        <p:txBody>
-          <a:bodyPr anchorCtr="0" anchor="ctr" bIns="91425" lIns="274300" spcFirstLastPara="1" rIns="91425" wrap="square" tIns="91425">
-            <a:noAutofit/>
-          </a:bodyPr>
-          <a:lstStyle/>
-          <a:p>
-            <a:pPr indent="0" lvl="0" marL="0" rtl="0" algn="l">
-              <a:spcBef>
-                <a:spcPts val="0"/>
-              </a:spcBef>
-              <a:spcAft>
-                <a:spcPts val="0"/>
-              </a:spcAft>
-              <a:buNone/>
-            </a:pPr>
-            <a:r>
-              <a:rPr lang="en"/>
-              <a:t>NYT-PROJ Grading</a:t>
-            </a:r>
-            <a:endParaRPr/>
-          </a:p>
-        </p:txBody>
-      </p:sp>
-      <p:sp>
-        <p:nvSpPr>
-          <p:cNvPr id="132" name="Google Shape;132;p21"/>
-          <p:cNvSpPr txBox="1"/>
-          <p:nvPr>
-            <p:ph idx="1" type="body"/>
-          </p:nvPr>
-        </p:nvSpPr>
-        <p:spPr>
-          <a:xfrm>
-            <a:off x="274320" y="914400"/>
-            <a:ext cx="8595300" cy="4114800"/>
-          </a:xfrm>
-          <a:prstGeom prst="rect">
-            <a:avLst/>
-          </a:prstGeom>
-        </p:spPr>
-        <p:txBody>
-          <a:bodyPr anchorCtr="0" anchor="t" bIns="0" lIns="0" spcFirstLastPara="1" rIns="0" wrap="square" tIns="0">
-            <a:noAutofit/>
-          </a:bodyPr>
-          <a:lstStyle/>
-          <a:p>
-            <a:pPr indent="0" lvl="0" marL="0" rtl="0" algn="l">
-              <a:spcBef>
-                <a:spcPts val="0"/>
-              </a:spcBef>
-              <a:spcAft>
-                <a:spcPts val="0"/>
-              </a:spcAft>
-              <a:buNone/>
-            </a:pPr>
-            <a:r>
-              <a:rPr lang="en"/>
-              <a:t>Six submissions and one presentation</a:t>
-            </a:r>
-            <a:endParaRPr/>
-          </a:p>
-          <a:p>
-            <a:pPr indent="-342900" lvl="0" marL="457200" rtl="0" algn="l">
-              <a:spcBef>
-                <a:spcPts val="1200"/>
-              </a:spcBef>
-              <a:spcAft>
-                <a:spcPts val="0"/>
-              </a:spcAft>
-              <a:buSzPts val="1800"/>
-              <a:buAutoNum type="arabicPeriod"/>
-            </a:pPr>
-            <a:r>
-              <a:rPr lang="en"/>
-              <a:t>Paper outline = 5%</a:t>
-            </a:r>
-            <a:endParaRPr/>
-          </a:p>
-          <a:p>
-            <a:pPr indent="-342900" lvl="0" marL="457200" rtl="0" algn="l">
-              <a:spcBef>
-                <a:spcPts val="0"/>
-              </a:spcBef>
-              <a:spcAft>
-                <a:spcPts val="0"/>
-              </a:spcAft>
-              <a:buSzPts val="1800"/>
-              <a:buAutoNum type="arabicPeriod"/>
-            </a:pPr>
-            <a:r>
-              <a:rPr lang="en"/>
-              <a:t>Related work = 10%</a:t>
-            </a:r>
-            <a:endParaRPr/>
-          </a:p>
-          <a:p>
-            <a:pPr indent="-342900" lvl="0" marL="457200" rtl="0" algn="l">
-              <a:spcBef>
-                <a:spcPts val="0"/>
-              </a:spcBef>
-              <a:spcAft>
-                <a:spcPts val="0"/>
-              </a:spcAft>
-              <a:buSzPts val="1800"/>
-              <a:buAutoNum type="arabicPeriod"/>
-            </a:pPr>
-            <a:r>
-              <a:rPr lang="en"/>
-              <a:t>Contributions 1 = 5%</a:t>
-            </a:r>
-            <a:endParaRPr/>
-          </a:p>
-          <a:p>
-            <a:pPr indent="-342900" lvl="0" marL="457200" rtl="0" algn="l">
-              <a:spcBef>
-                <a:spcPts val="0"/>
-              </a:spcBef>
-              <a:spcAft>
-                <a:spcPts val="0"/>
-              </a:spcAft>
-              <a:buSzPts val="1800"/>
-              <a:buAutoNum type="arabicPeriod"/>
-            </a:pPr>
-            <a:r>
-              <a:rPr lang="en"/>
-              <a:t>Contributions 2 = 10%</a:t>
-            </a:r>
-            <a:endParaRPr/>
-          </a:p>
-          <a:p>
-            <a:pPr indent="-342900" lvl="0" marL="457200" rtl="0" algn="l">
-              <a:spcBef>
-                <a:spcPts val="0"/>
-              </a:spcBef>
-              <a:spcAft>
-                <a:spcPts val="0"/>
-              </a:spcAft>
-              <a:buSzPts val="1800"/>
-              <a:buAutoNum type="arabicPeriod"/>
-            </a:pPr>
-            <a:r>
-              <a:rPr lang="en"/>
-              <a:t>Paper draft = 15%</a:t>
-            </a:r>
-            <a:endParaRPr/>
-          </a:p>
-          <a:p>
-            <a:pPr indent="-342900" lvl="0" marL="457200" rtl="0" algn="l">
-              <a:spcBef>
-                <a:spcPts val="0"/>
-              </a:spcBef>
-              <a:spcAft>
-                <a:spcPts val="0"/>
-              </a:spcAft>
-              <a:buSzPts val="1800"/>
-              <a:buAutoNum type="arabicPeriod"/>
-            </a:pPr>
-            <a:r>
-              <a:rPr lang="en"/>
-              <a:t>Final paper = 40%</a:t>
-            </a:r>
-            <a:endParaRPr/>
-          </a:p>
-          <a:p>
-            <a:pPr indent="-342900" lvl="0" marL="457200" rtl="0" algn="l">
-              <a:spcBef>
-                <a:spcPts val="0"/>
-              </a:spcBef>
-              <a:spcAft>
-                <a:spcPts val="0"/>
-              </a:spcAft>
-              <a:buSzPts val="1800"/>
-              <a:buAutoNum type="arabicPeriod"/>
-            </a:pPr>
-            <a:r>
-              <a:rPr lang="en"/>
-              <a:t>Final presentation = 15%</a:t>
-            </a:r>
-            <a:endParaRPr/>
-          </a:p>
-          <a:p>
-            <a:pPr indent="0" lvl="0" marL="0" rtl="0" algn="l">
-              <a:spcBef>
-                <a:spcPts val="1200"/>
-              </a:spcBef>
-              <a:spcAft>
-                <a:spcPts val="1200"/>
-              </a:spcAft>
-              <a:buNone/>
-            </a:pPr>
-            <a:r>
-              <a:t/>
-            </a:r>
-            <a:endParaRPr/>
-          </a:p>
-        </p:txBody>
-      </p:sp>
-      <p:sp>
-        <p:nvSpPr>
-          <p:cNvPr id="133" name="Google Shape;133;p21"/>
-          <p:cNvSpPr txBox="1"/>
-          <p:nvPr>
-            <p:ph idx="12" type="sldNum"/>
-          </p:nvPr>
-        </p:nvSpPr>
-        <p:spPr>
-          <a:xfrm>
-            <a:off x="7315209" y="4229101"/>
-            <a:ext cx="1828800" cy="914400"/>
-          </a:xfrm>
-          <a:prstGeom prst="rect">
-            <a:avLst/>
-          </a:prstGeom>
-        </p:spPr>
-        <p:txBody>
-          <a:bodyPr anchorCtr="0" anchor="b" bIns="91425" lIns="91425" spcFirstLastPara="1" rIns="91425" wrap="square" tIns="91425">
-            <a:noAutofit/>
-          </a:bodyPr>
-          <a:lstStyle/>
-          <a:p>
-            <a:pPr indent="0" lvl="0" marL="0" rtl="0" algn="r">
-              <a:spcBef>
-                <a:spcPts val="0"/>
-              </a:spcBef>
-              <a:spcAft>
-                <a:spcPts val="0"/>
-              </a:spcAft>
-              <a:buNone/>
-            </a:pPr>
-            <a:fld id="{00000000-1234-1234-1234-123412341234}" type="slidenum">
-              <a:rPr lang="en"/>
-              <a:t>‹#›</a:t>
-            </a:fld>
-            <a:endParaRPr/>
-          </a:p>
-          <a:p>
-            <a:pPr indent="0" lvl="0" marL="0" rtl="0" algn="r">
-              <a:spcBef>
-                <a:spcPts val="0"/>
-              </a:spcBef>
-              <a:spcAft>
-                <a:spcPts val="0"/>
-              </a:spcAft>
-              <a:buNone/>
-            </a:pPr>
-            <a:r>
-              <a:rPr b="0" lang="en" sz="1000" u="sng">
-                <a:solidFill>
-                  <a:schemeClr val="hlink"/>
-                </a:solidFill>
-                <a:hlinkClick r:id="rId3"/>
-              </a:rPr>
-              <a:t>uni1.de/nyt</a:t>
-            </a:r>
-            <a:r>
-              <a:rPr b="0" lang="en" sz="1000"/>
-              <a:t> </a:t>
-            </a:r>
-            <a:endParaRPr b="0" sz="1000"/>
-          </a:p>
-        </p:txBody>
-      </p:sp>
-    </p:spTree>
-  </p:cSld>
-  <p:clrMapOvr>
-    <a:masterClrMapping/>
-  </p:clrMapOvr>
-</p:sld>
-</file>
-
 <file path=ppt/slides/slide15.xml><?xml version="1.0" encoding="utf-8"?>
 <p:sld xmlns:a="http://schemas.openxmlformats.org/drawingml/2006/main" xmlns:r="http://schemas.openxmlformats.org/officeDocument/2006/relationships" xmlns:mc="http://schemas.openxmlformats.org/markup-compatibility/2006" xmlns:mv="urn:schemas-microsoft-com:mac:vml" xmlns:p="http://schemas.openxmlformats.org/presentationml/2006/main" xmlns:c="http://schemas.openxmlformats.org/drawingml/2006/chart" xmlns:dgm="http://schemas.openxmlformats.org/drawingml/2006/diagram" xmlns:o="urn:schemas-microsoft-com:office:office" xmlns:v="urn:schemas-microsoft-com:vml" xmlns:pvml="urn:schemas-microsoft-com:office:powerpoint" xmlns:com="http://schemas.openxmlformats.org/drawingml/2006/compatibility" xmlns:p14="http://schemas.microsoft.com/office/powerpoint/2010/main" xmlns:p15="http://schemas.microsoft.com/office/powerpoint/2012/main" xmlns:ahyp="http://schemas.microsoft.com/office/drawing/2018/hyperlinkcolor">
   <p:cSld>
@@ -10375,7 +10206,7 @@
 </file>
 
 <file path=ppt/slides/slide18.xml><?xml version="1.0" encoding="utf-8"?>
-<p:sld xmlns:a="http://schemas.openxmlformats.org/drawingml/2006/main" xmlns:r="http://schemas.openxmlformats.org/officeDocument/2006/relationships" xmlns:mc="http://schemas.openxmlformats.org/markup-compatibility/2006" xmlns:mv="urn:schemas-microsoft-com:mac:vml" xmlns:p="http://schemas.openxmlformats.org/presentationml/2006/main" xmlns:c="http://schemas.openxmlformats.org/drawingml/2006/chart" xmlns:dgm="http://schemas.openxmlformats.org/drawingml/2006/diagram" xmlns:o="urn:schemas-microsoft-com:office:office" xmlns:v="urn:schemas-microsoft-com:vml" xmlns:pvml="urn:schemas-microsoft-com:office:powerpoint" xmlns:com="http://schemas.openxmlformats.org/drawingml/2006/compatibility" xmlns:p14="http://schemas.microsoft.com/office/powerpoint/2010/main" xmlns:p15="http://schemas.microsoft.com/office/powerpoint/2012/main" xmlns:ahyp="http://schemas.microsoft.com/office/drawing/2018/hyperlinkcolor">
+<p:sld xmlns:a="http://schemas.openxmlformats.org/drawingml/2006/main" xmlns:r="http://schemas.openxmlformats.org/officeDocument/2006/relationships" xmlns:mc="http://schemas.openxmlformats.org/markup-compatibility/2006" xmlns:mv="urn:schemas-microsoft-com:mac:vml" xmlns:p="http://schemas.openxmlformats.org/presentationml/2006/main" xmlns:c="http://schemas.openxmlformats.org/drawingml/2006/chart" xmlns:dgm="http://schemas.openxmlformats.org/drawingml/2006/diagram" xmlns:o="urn:schemas-microsoft-com:office:office" xmlns:v="urn:schemas-microsoft-com:vml" xmlns:pvml="urn:schemas-microsoft-com:office:powerpoint" xmlns:com="http://schemas.openxmlformats.org/drawingml/2006/compatibility" xmlns:p14="http://schemas.microsoft.com/office/powerpoint/2010/main" xmlns:p15="http://schemas.microsoft.com/office/powerpoint/2012/main" xmlns:ahyp="http://schemas.microsoft.com/office/drawing/2018/hyperlinkcolor" show="0">
   <p:cSld>
     <p:spTree>
       <p:nvGrpSpPr>
@@ -11072,7 +10903,11 @@
             </a:pPr>
             <a:r>
               <a:rPr b="1" lang="en"/>
-              <a:t>Learning objectives</a:t>
+              <a:t>General </a:t>
+            </a:r>
+            <a:r>
+              <a:rPr b="1" lang="en"/>
+              <a:t>objectives (NYT-VUE)</a:t>
             </a:r>
             <a:endParaRPr b="1"/>
           </a:p>
@@ -11190,7 +11025,7 @@
             </a:pPr>
             <a:r>
               <a:rPr b="1" lang="en"/>
-              <a:t>Project objectives</a:t>
+              <a:t>Project objectives (NYT-PROJ)</a:t>
             </a:r>
             <a:endParaRPr b="1"/>
           </a:p>
@@ -11308,6 +11143,142 @@
           <p:cNvPr id="176" name="Google Shape;176;p27"/>
           <p:cNvSpPr txBox="1"/>
           <p:nvPr>
+            <p:ph idx="1" type="body"/>
+          </p:nvPr>
+        </p:nvSpPr>
+        <p:spPr>
+          <a:xfrm>
+            <a:off x="274320" y="914400"/>
+            <a:ext cx="8595300" cy="4114800"/>
+          </a:xfrm>
+          <a:prstGeom prst="rect">
+            <a:avLst/>
+          </a:prstGeom>
+        </p:spPr>
+        <p:txBody>
+          <a:bodyPr anchorCtr="0" anchor="t" bIns="0" lIns="0" spcFirstLastPara="1" rIns="0" wrap="square" tIns="0">
+            <a:noAutofit/>
+          </a:bodyPr>
+          <a:lstStyle/>
+          <a:p>
+            <a:pPr indent="0" lvl="0" marL="0" rtl="0" algn="l">
+              <a:spcBef>
+                <a:spcPts val="0"/>
+              </a:spcBef>
+              <a:spcAft>
+                <a:spcPts val="0"/>
+              </a:spcAft>
+              <a:buClr>
+                <a:schemeClr val="dk1"/>
+              </a:buClr>
+              <a:buSzPts val="1100"/>
+              <a:buFont typeface="Arial"/>
+              <a:buNone/>
+            </a:pPr>
+            <a:r>
+              <a:rPr b="1" lang="en"/>
+              <a:t>Course organization</a:t>
+            </a:r>
+            <a:endParaRPr b="1"/>
+          </a:p>
+          <a:p>
+            <a:pPr indent="-342900" lvl="0" marL="457200" rtl="0" algn="l">
+              <a:spcBef>
+                <a:spcPts val="1200"/>
+              </a:spcBef>
+              <a:spcAft>
+                <a:spcPts val="0"/>
+              </a:spcAft>
+              <a:buSzPts val="1800"/>
+              <a:buChar char="●"/>
+            </a:pPr>
+            <a:r>
+              <a:rPr lang="en"/>
+              <a:t>See index tab on </a:t>
+            </a:r>
+            <a:r>
+              <a:rPr lang="en" u="sng">
+                <a:solidFill>
+                  <a:schemeClr val="hlink"/>
+                </a:solidFill>
+                <a:hlinkClick r:id="rId3"/>
+              </a:rPr>
+              <a:t>https://uni1.de/nyt/index</a:t>
+            </a:r>
+            <a:r>
+              <a:rPr lang="en"/>
+              <a:t> </a:t>
+            </a:r>
+            <a:endParaRPr/>
+          </a:p>
+          <a:p>
+            <a:pPr indent="0" lvl="0" marL="0" rtl="0" algn="l">
+              <a:spcBef>
+                <a:spcPts val="1200"/>
+              </a:spcBef>
+              <a:spcAft>
+                <a:spcPts val="0"/>
+              </a:spcAft>
+              <a:buClr>
+                <a:schemeClr val="dk1"/>
+              </a:buClr>
+              <a:buSzPts val="1100"/>
+              <a:buFont typeface="Arial"/>
+              <a:buNone/>
+            </a:pPr>
+            <a:r>
+              <a:rPr b="1" lang="en"/>
+              <a:t>Course schedule</a:t>
+            </a:r>
+            <a:endParaRPr b="1"/>
+          </a:p>
+          <a:p>
+            <a:pPr indent="-342900" lvl="0" marL="457200" rtl="0" algn="l">
+              <a:spcBef>
+                <a:spcPts val="1200"/>
+              </a:spcBef>
+              <a:spcAft>
+                <a:spcPts val="0"/>
+              </a:spcAft>
+              <a:buSzPts val="1800"/>
+              <a:buChar char="●"/>
+            </a:pPr>
+            <a:r>
+              <a:rPr lang="en"/>
+              <a:t>See s</a:t>
+            </a:r>
+            <a:r>
+              <a:rPr lang="en"/>
+              <a:t>chedule</a:t>
+            </a:r>
+            <a:r>
+              <a:rPr lang="en"/>
+              <a:t> tab on Course organization doc</a:t>
+            </a:r>
+            <a:endParaRPr/>
+          </a:p>
+          <a:p>
+            <a:pPr indent="0" lvl="0" marL="0" rtl="0" algn="l">
+              <a:spcBef>
+                <a:spcPts val="1200"/>
+              </a:spcBef>
+              <a:spcAft>
+                <a:spcPts val="1200"/>
+              </a:spcAft>
+              <a:buNone/>
+            </a:pPr>
+            <a:r>
+              <a:t/>
+            </a:r>
+            <a:endParaRPr/>
+          </a:p>
+        </p:txBody>
+      </p:sp>
+      <p:sp>
+        <p:nvSpPr>
+          <p:cNvPr id="177" name="Google Shape;177;p27"/>
+          <p:cNvSpPr txBox="1"/>
+          <p:nvPr>
             <p:ph type="title"/>
           </p:nvPr>
         </p:nvSpPr>
@@ -11338,173 +11309,6 @@
             <a:r>
               <a:rPr lang="en"/>
               <a:t>Course Organization</a:t>
-            </a:r>
-            <a:endParaRPr/>
-          </a:p>
-        </p:txBody>
-      </p:sp>
-      <p:sp>
-        <p:nvSpPr>
-          <p:cNvPr id="177" name="Google Shape;177;p27"/>
-          <p:cNvSpPr txBox="1"/>
-          <p:nvPr>
-            <p:ph idx="1" type="body"/>
-          </p:nvPr>
-        </p:nvSpPr>
-        <p:spPr>
-          <a:xfrm>
-            <a:off x="274320" y="914400"/>
-            <a:ext cx="8595300" cy="4114800"/>
-          </a:xfrm>
-          <a:prstGeom prst="rect">
-            <a:avLst/>
-          </a:prstGeom>
-        </p:spPr>
-        <p:txBody>
-          <a:bodyPr anchorCtr="0" anchor="t" bIns="0" lIns="0" spcFirstLastPara="1" rIns="0" wrap="square" tIns="0">
-            <a:noAutofit/>
-          </a:bodyPr>
-          <a:lstStyle/>
-          <a:p>
-            <a:pPr indent="0" lvl="0" marL="0" rtl="0" algn="l">
-              <a:spcBef>
-                <a:spcPts val="0"/>
-              </a:spcBef>
-              <a:spcAft>
-                <a:spcPts val="0"/>
-              </a:spcAft>
-              <a:buClr>
-                <a:schemeClr val="dk1"/>
-              </a:buClr>
-              <a:buSzPts val="1100"/>
-              <a:buFont typeface="Arial"/>
-              <a:buNone/>
-            </a:pPr>
-            <a:r>
-              <a:rPr b="1" lang="en"/>
-              <a:t>Course organization</a:t>
-            </a:r>
-            <a:endParaRPr b="1"/>
-          </a:p>
-          <a:p>
-            <a:pPr indent="-342900" lvl="0" marL="457200" rtl="0" algn="l">
-              <a:spcBef>
-                <a:spcPts val="1200"/>
-              </a:spcBef>
-              <a:spcAft>
-                <a:spcPts val="0"/>
-              </a:spcAft>
-              <a:buSzPts val="1800"/>
-              <a:buChar char="●"/>
-            </a:pPr>
-            <a:r>
-              <a:rPr lang="en"/>
-              <a:t>See </a:t>
-            </a:r>
-            <a:r>
-              <a:rPr lang="en" u="sng">
-                <a:solidFill>
-                  <a:schemeClr val="hlink"/>
-                </a:solidFill>
-                <a:hlinkClick r:id="rId3"/>
-              </a:rPr>
-              <a:t>https://nyt.uni1.de</a:t>
-            </a:r>
-            <a:r>
-              <a:rPr lang="en"/>
-              <a:t>   </a:t>
-            </a:r>
-            <a:endParaRPr/>
-          </a:p>
-          <a:p>
-            <a:pPr indent="0" lvl="0" marL="0" rtl="0" algn="l">
-              <a:spcBef>
-                <a:spcPts val="1200"/>
-              </a:spcBef>
-              <a:spcAft>
-                <a:spcPts val="0"/>
-              </a:spcAft>
-              <a:buClr>
-                <a:schemeClr val="dk1"/>
-              </a:buClr>
-              <a:buSzPts val="1100"/>
-              <a:buFont typeface="Arial"/>
-              <a:buNone/>
-            </a:pPr>
-            <a:r>
-              <a:rPr b="1" lang="en"/>
-              <a:t>Course schedule</a:t>
-            </a:r>
-            <a:endParaRPr b="1"/>
-          </a:p>
-          <a:p>
-            <a:pPr indent="-342900" lvl="0" marL="457200" rtl="0" algn="l">
-              <a:spcBef>
-                <a:spcPts val="1200"/>
-              </a:spcBef>
-              <a:spcAft>
-                <a:spcPts val="0"/>
-              </a:spcAft>
-              <a:buSzPts val="1800"/>
-              <a:buChar char="●"/>
-            </a:pPr>
-            <a:r>
-              <a:rPr lang="en"/>
-              <a:t>See </a:t>
-            </a:r>
-            <a:r>
-              <a:rPr b="1" lang="en"/>
-              <a:t>Schedule</a:t>
-            </a:r>
-            <a:r>
-              <a:rPr lang="en"/>
-              <a:t> tab on Course organization doc</a:t>
-            </a:r>
-            <a:endParaRPr/>
-          </a:p>
-          <a:p>
-            <a:pPr indent="0" lvl="0" marL="0" rtl="0" algn="l">
-              <a:spcBef>
-                <a:spcPts val="1200"/>
-              </a:spcBef>
-              <a:spcAft>
-                <a:spcPts val="0"/>
-              </a:spcAft>
-              <a:buClr>
-                <a:schemeClr val="dk1"/>
-              </a:buClr>
-              <a:buSzPts val="1100"/>
-              <a:buFont typeface="Arial"/>
-              <a:buNone/>
-            </a:pPr>
-            <a:r>
-              <a:rPr b="1" lang="en"/>
-              <a:t>Project allocation</a:t>
-            </a:r>
-            <a:endParaRPr b="1"/>
-          </a:p>
-          <a:p>
-            <a:pPr indent="-342900" lvl="0" marL="457200" rtl="0" algn="l">
-              <a:spcBef>
-                <a:spcPts val="1200"/>
-              </a:spcBef>
-              <a:spcAft>
-                <a:spcPts val="0"/>
-              </a:spcAft>
-              <a:buSzPts val="1800"/>
-              <a:buChar char="●"/>
-            </a:pPr>
-            <a:r>
-              <a:rPr lang="en"/>
-              <a:t>See </a:t>
-            </a:r>
-            <a:r>
-              <a:rPr b="1" lang="en"/>
-              <a:t>Projects </a:t>
-            </a:r>
-            <a:r>
-              <a:rPr lang="en"/>
-              <a:t>tab on Course organization doc </a:t>
             </a:r>
             <a:endParaRPr/>
           </a:p>
@@ -12182,6 +11986,190 @@
           <p:cNvPr id="197" name="Google Shape;197;p30"/>
           <p:cNvSpPr txBox="1"/>
           <p:nvPr>
+            <p:ph type="ctrTitle"/>
+          </p:nvPr>
+        </p:nvSpPr>
+        <p:spPr>
+          <a:xfrm>
+            <a:off x="0" y="0"/>
+            <a:ext cx="9144000" cy="2388900"/>
+          </a:xfrm>
+          <a:prstGeom prst="rect">
+            <a:avLst/>
+          </a:prstGeom>
+        </p:spPr>
+        <p:txBody>
+          <a:bodyPr anchorCtr="0" anchor="b" bIns="274300" lIns="91425" spcFirstLastPara="1" rIns="91425" wrap="square" tIns="91425">
+            <a:noAutofit/>
+          </a:bodyPr>
+          <a:lstStyle/>
+          <a:p>
+            <a:pPr indent="0" lvl="0" marL="0" rtl="0" algn="ctr">
+              <a:spcBef>
+                <a:spcPts val="0"/>
+              </a:spcBef>
+              <a:spcAft>
+                <a:spcPts val="0"/>
+              </a:spcAft>
+              <a:buNone/>
+            </a:pPr>
+            <a:r>
+              <a:rPr lang="en"/>
+              <a:t>Thank you! Any questions?</a:t>
+            </a:r>
+            <a:endParaRPr/>
+          </a:p>
+        </p:txBody>
+      </p:sp>
+      <p:sp>
+        <p:nvSpPr>
+          <p:cNvPr id="198" name="Google Shape;198;p30"/>
+          <p:cNvSpPr txBox="1"/>
+          <p:nvPr>
+            <p:ph idx="1" type="subTitle"/>
+          </p:nvPr>
+        </p:nvSpPr>
+        <p:spPr>
+          <a:xfrm>
+            <a:off x="0" y="2569475"/>
+            <a:ext cx="9144000" cy="2574000"/>
+          </a:xfrm>
+          <a:prstGeom prst="rect">
+            <a:avLst/>
+          </a:prstGeom>
+        </p:spPr>
+        <p:txBody>
+          <a:bodyPr anchorCtr="0" anchor="t" bIns="91425" lIns="91425" spcFirstLastPara="1" rIns="91425" wrap="square" tIns="274300">
+            <a:noAutofit/>
+          </a:bodyPr>
+          <a:lstStyle/>
+          <a:p>
+            <a:pPr indent="0" lvl="0" marL="0" rtl="0" algn="ctr">
+              <a:lnSpc>
+                <a:spcPct val="150000"/>
+              </a:lnSpc>
+              <a:spcBef>
+                <a:spcPts val="0"/>
+              </a:spcBef>
+              <a:spcAft>
+                <a:spcPts val="0"/>
+              </a:spcAft>
+              <a:buNone/>
+            </a:pPr>
+            <a:r>
+              <a:rPr lang="en" u="sng">
+                <a:solidFill>
+                  <a:schemeClr val="hlink"/>
+                </a:solidFill>
+                <a:hlinkClick r:id="rId3"/>
+              </a:rPr>
+              <a:t>dirk.riehle@fau.de</a:t>
+            </a:r>
+            <a:r>
+              <a:rPr lang="en"/>
+              <a:t> </a:t>
+            </a:r>
+            <a:r>
+              <a:rPr lang="en" sz="2400"/>
+              <a:t>–</a:t>
+            </a:r>
+            <a:r>
+              <a:rPr lang="en"/>
+              <a:t> </a:t>
+            </a:r>
+            <a:r>
+              <a:rPr lang="en" u="sng">
+                <a:solidFill>
+                  <a:schemeClr val="hlink"/>
+                </a:solidFill>
+                <a:hlinkClick r:id="rId4"/>
+              </a:rPr>
+              <a:t>https://oss.cs.fau.de</a:t>
+            </a:r>
+            <a:endParaRPr/>
+          </a:p>
+          <a:p>
+            <a:pPr indent="0" lvl="0" marL="0" rtl="0" algn="ctr">
+              <a:lnSpc>
+                <a:spcPct val="150000"/>
+              </a:lnSpc>
+              <a:spcBef>
+                <a:spcPts val="0"/>
+              </a:spcBef>
+              <a:spcAft>
+                <a:spcPts val="0"/>
+              </a:spcAft>
+              <a:buNone/>
+            </a:pPr>
+            <a:r>
+              <a:rPr lang="en" sz="2400" u="sng">
+                <a:solidFill>
+                  <a:schemeClr val="hlink"/>
+                </a:solidFill>
+                <a:hlinkClick r:id="rId5"/>
+              </a:rPr>
+              <a:t>dirk@riehle.org</a:t>
+            </a:r>
+            <a:r>
+              <a:rPr lang="en" sz="2400"/>
+              <a:t> – </a:t>
+            </a:r>
+            <a:r>
+              <a:rPr lang="en" sz="2400" u="sng">
+                <a:solidFill>
+                  <a:schemeClr val="hlink"/>
+                </a:solidFill>
+                <a:hlinkClick r:id="rId6"/>
+              </a:rPr>
+              <a:t>https://dirkriehle.com</a:t>
+            </a:r>
+            <a:r>
+              <a:rPr lang="en" sz="2400"/>
+              <a:t> – </a:t>
+            </a:r>
+            <a:r>
+              <a:rPr lang="en" sz="2400" u="sng">
+                <a:solidFill>
+                  <a:schemeClr val="hlink"/>
+                </a:solidFill>
+                <a:hlinkClick r:id="rId7"/>
+              </a:rPr>
+              <a:t>@dirkriehle</a:t>
+            </a:r>
+            <a:endParaRPr sz="2400"/>
+          </a:p>
+        </p:txBody>
+      </p:sp>
+    </p:spTree>
+  </p:cSld>
+  <p:clrMapOvr>
+    <a:masterClrMapping/>
+  </p:clrMapOvr>
+</p:sld>
+</file>
+
+<file path=ppt/slides/slide24.xml><?xml version="1.0" encoding="utf-8"?>
+<p:sld xmlns:a="http://schemas.openxmlformats.org/drawingml/2006/main" xmlns:r="http://schemas.openxmlformats.org/officeDocument/2006/relationships" xmlns:mc="http://schemas.openxmlformats.org/markup-compatibility/2006" xmlns:mv="urn:schemas-microsoft-com:mac:vml" xmlns:p="http://schemas.openxmlformats.org/presentationml/2006/main" xmlns:c="http://schemas.openxmlformats.org/drawingml/2006/chart" xmlns:dgm="http://schemas.openxmlformats.org/drawingml/2006/diagram" xmlns:o="urn:schemas-microsoft-com:office:office" xmlns:v="urn:schemas-microsoft-com:vml" xmlns:pvml="urn:schemas-microsoft-com:office:powerpoint" xmlns:com="http://schemas.openxmlformats.org/drawingml/2006/compatibility" xmlns:p14="http://schemas.microsoft.com/office/powerpoint/2010/main" xmlns:p15="http://schemas.microsoft.com/office/powerpoint/2012/main" xmlns:ahyp="http://schemas.microsoft.com/office/drawing/2018/hyperlinkcolor">
+  <p:cSld>
+    <p:spTree>
+      <p:nvGrpSpPr>
+        <p:cNvPr id="202" name="Shape 202"/>
+        <p:cNvGrpSpPr/>
+        <p:nvPr/>
+      </p:nvGrpSpPr>
+      <p:grpSpPr>
+        <a:xfrm>
+          <a:off x="0" y="0"/>
+          <a:ext cx="0" cy="0"/>
+          <a:chOff x="0" y="0"/>
+          <a:chExt cx="0" cy="0"/>
+        </a:xfrm>
+      </p:grpSpPr>
+      <p:sp>
+        <p:nvSpPr>
+          <p:cNvPr id="203" name="Google Shape;203;p31"/>
+          <p:cNvSpPr txBox="1"/>
+          <p:nvPr>
             <p:ph type="title"/>
           </p:nvPr>
         </p:nvSpPr>
@@ -12211,7 +12199,7 @@
             </a:pPr>
             <a:r>
               <a:rPr lang="en"/>
-              <a:t>This Semester’s Projects</a:t>
+              <a:t>Legal Notices</a:t>
             </a:r>
             <a:endParaRPr/>
           </a:p>
@@ -12219,7 +12207,72 @@
       </p:sp>
       <p:sp>
         <p:nvSpPr>
-          <p:cNvPr id="198" name="Google Shape;198;p30"/>
+          <p:cNvPr id="204" name="Google Shape;204;p31"/>
+          <p:cNvSpPr txBox="1"/>
+          <p:nvPr>
+            <p:ph idx="12" type="sldNum"/>
+          </p:nvPr>
+        </p:nvSpPr>
+        <p:spPr>
+          <a:xfrm>
+            <a:off x="7315209" y="4229101"/>
+            <a:ext cx="1828800" cy="914400"/>
+          </a:xfrm>
+          <a:prstGeom prst="rect">
+            <a:avLst/>
+          </a:prstGeom>
+        </p:spPr>
+        <p:txBody>
+          <a:bodyPr anchorCtr="0" anchor="b" bIns="91425" lIns="91425" spcFirstLastPara="1" rIns="91425" wrap="square" tIns="91425">
+            <a:noAutofit/>
+          </a:bodyPr>
+          <a:lstStyle/>
+          <a:p>
+            <a:pPr indent="0" lvl="0" marL="0" rtl="0" algn="r">
+              <a:spcBef>
+                <a:spcPts val="0"/>
+              </a:spcBef>
+              <a:spcAft>
+                <a:spcPts val="0"/>
+              </a:spcAft>
+              <a:buNone/>
+            </a:pPr>
+            <a:fld id="{00000000-1234-1234-1234-123412341234}" type="slidenum">
+              <a:rPr lang="en"/>
+              <a:t>‹#›</a:t>
+            </a:fld>
+            <a:endParaRPr/>
+          </a:p>
+          <a:p>
+            <a:pPr indent="0" lvl="0" marL="0" rtl="0" algn="r">
+              <a:spcBef>
+                <a:spcPts val="0"/>
+              </a:spcBef>
+              <a:spcAft>
+                <a:spcPts val="0"/>
+              </a:spcAft>
+              <a:buNone/>
+            </a:pPr>
+            <a:r>
+              <a:rPr b="0" lang="en" sz="1000" u="sng">
+                <a:solidFill>
+                  <a:schemeClr val="hlink"/>
+                </a:solidFill>
+                <a:hlinkClick r:id="rId3"/>
+              </a:rPr>
+              <a:t>uni1.de/nyt</a:t>
+            </a:r>
+            <a:r>
+              <a:rPr b="0" lang="en" sz="1000"/>
+              <a:t> </a:t>
+            </a:r>
+            <a:endParaRPr b="0" sz="1000"/>
+          </a:p>
+        </p:txBody>
+      </p:sp>
+      <p:sp>
+        <p:nvSpPr>
+          <p:cNvPr id="205" name="Google Shape;205;p31"/>
           <p:cNvSpPr txBox="1"/>
           <p:nvPr>
             <p:ph idx="1" type="body"/>
@@ -12245,446 +12298,6 @@
                 <a:spcPts val="0"/>
               </a:spcBef>
               <a:spcAft>
-                <a:spcPts val="1200"/>
-              </a:spcAft>
-              <a:buNone/>
-            </a:pPr>
-            <a:r>
-              <a:rPr lang="en"/>
-              <a:t>Let’s see… </a:t>
-            </a:r>
-            <a:r>
-              <a:rPr lang="en" u="sng">
-                <a:solidFill>
-                  <a:schemeClr val="hlink"/>
-                </a:solidFill>
-                <a:hlinkClick r:id="rId3"/>
-              </a:rPr>
-              <a:t>https://nyt.uni1.de</a:t>
-            </a:r>
-            <a:r>
-              <a:rPr lang="en"/>
-              <a:t> </a:t>
-            </a:r>
-            <a:endParaRPr/>
-          </a:p>
-        </p:txBody>
-      </p:sp>
-      <p:sp>
-        <p:nvSpPr>
-          <p:cNvPr id="199" name="Google Shape;199;p30"/>
-          <p:cNvSpPr txBox="1"/>
-          <p:nvPr>
-            <p:ph idx="12" type="sldNum"/>
-          </p:nvPr>
-        </p:nvSpPr>
-        <p:spPr>
-          <a:xfrm>
-            <a:off x="7315209" y="4229101"/>
-            <a:ext cx="1828800" cy="914400"/>
-          </a:xfrm>
-          <a:prstGeom prst="rect">
-            <a:avLst/>
-          </a:prstGeom>
-        </p:spPr>
-        <p:txBody>
-          <a:bodyPr anchorCtr="0" anchor="b" bIns="91425" lIns="91425" spcFirstLastPara="1" rIns="91425" wrap="square" tIns="91425">
-            <a:noAutofit/>
-          </a:bodyPr>
-          <a:lstStyle/>
-          <a:p>
-            <a:pPr indent="0" lvl="0" marL="0" rtl="0" algn="r">
-              <a:spcBef>
-                <a:spcPts val="0"/>
-              </a:spcBef>
-              <a:spcAft>
-                <a:spcPts val="0"/>
-              </a:spcAft>
-              <a:buNone/>
-            </a:pPr>
-            <a:fld id="{00000000-1234-1234-1234-123412341234}" type="slidenum">
-              <a:rPr lang="en"/>
-              <a:t>‹#›</a:t>
-            </a:fld>
-            <a:endParaRPr/>
-          </a:p>
-          <a:p>
-            <a:pPr indent="0" lvl="0" marL="0" rtl="0" algn="r">
-              <a:spcBef>
-                <a:spcPts val="0"/>
-              </a:spcBef>
-              <a:spcAft>
-                <a:spcPts val="0"/>
-              </a:spcAft>
-              <a:buNone/>
-            </a:pPr>
-            <a:r>
-              <a:rPr b="0" lang="en" sz="1000" u="sng">
-                <a:solidFill>
-                  <a:schemeClr val="hlink"/>
-                </a:solidFill>
-                <a:hlinkClick r:id="rId4"/>
-              </a:rPr>
-              <a:t>uni1.de/nyt</a:t>
-            </a:r>
-            <a:r>
-              <a:rPr b="0" lang="en" sz="1000"/>
-              <a:t> </a:t>
-            </a:r>
-            <a:endParaRPr b="0" sz="1000"/>
-          </a:p>
-        </p:txBody>
-      </p:sp>
-    </p:spTree>
-  </p:cSld>
-  <p:clrMapOvr>
-    <a:masterClrMapping/>
-  </p:clrMapOvr>
-</p:sld>
-</file>
-
-<file path=ppt/slides/slide24.xml><?xml version="1.0" encoding="utf-8"?>
-<p:sld xmlns:a="http://schemas.openxmlformats.org/drawingml/2006/main" xmlns:r="http://schemas.openxmlformats.org/officeDocument/2006/relationships" xmlns:mc="http://schemas.openxmlformats.org/markup-compatibility/2006" xmlns:mv="urn:schemas-microsoft-com:mac:vml" xmlns:p="http://schemas.openxmlformats.org/presentationml/2006/main" xmlns:c="http://schemas.openxmlformats.org/drawingml/2006/chart" xmlns:dgm="http://schemas.openxmlformats.org/drawingml/2006/diagram" xmlns:o="urn:schemas-microsoft-com:office:office" xmlns:v="urn:schemas-microsoft-com:vml" xmlns:pvml="urn:schemas-microsoft-com:office:powerpoint" xmlns:com="http://schemas.openxmlformats.org/drawingml/2006/compatibility" xmlns:p14="http://schemas.microsoft.com/office/powerpoint/2010/main" xmlns:p15="http://schemas.microsoft.com/office/powerpoint/2012/main" xmlns:ahyp="http://schemas.microsoft.com/office/drawing/2018/hyperlinkcolor">
-  <p:cSld>
-    <p:spTree>
-      <p:nvGrpSpPr>
-        <p:cNvPr id="203" name="Shape 203"/>
-        <p:cNvGrpSpPr/>
-        <p:nvPr/>
-      </p:nvGrpSpPr>
-      <p:grpSpPr>
-        <a:xfrm>
-          <a:off x="0" y="0"/>
-          <a:ext cx="0" cy="0"/>
-          <a:chOff x="0" y="0"/>
-          <a:chExt cx="0" cy="0"/>
-        </a:xfrm>
-      </p:grpSpPr>
-      <p:sp>
-        <p:nvSpPr>
-          <p:cNvPr id="204" name="Google Shape;204;p31"/>
-          <p:cNvSpPr txBox="1"/>
-          <p:nvPr>
-            <p:ph type="ctrTitle"/>
-          </p:nvPr>
-        </p:nvSpPr>
-        <p:spPr>
-          <a:xfrm>
-            <a:off x="0" y="0"/>
-            <a:ext cx="9144000" cy="2388900"/>
-          </a:xfrm>
-          <a:prstGeom prst="rect">
-            <a:avLst/>
-          </a:prstGeom>
-        </p:spPr>
-        <p:txBody>
-          <a:bodyPr anchorCtr="0" anchor="b" bIns="274300" lIns="91425" spcFirstLastPara="1" rIns="91425" wrap="square" tIns="91425">
-            <a:noAutofit/>
-          </a:bodyPr>
-          <a:lstStyle/>
-          <a:p>
-            <a:pPr indent="0" lvl="0" marL="0" rtl="0" algn="ctr">
-              <a:spcBef>
-                <a:spcPts val="0"/>
-              </a:spcBef>
-              <a:spcAft>
-                <a:spcPts val="0"/>
-              </a:spcAft>
-              <a:buNone/>
-            </a:pPr>
-            <a:r>
-              <a:rPr lang="en"/>
-              <a:t>Thank you! Any questions?</a:t>
-            </a:r>
-            <a:endParaRPr/>
-          </a:p>
-        </p:txBody>
-      </p:sp>
-      <p:sp>
-        <p:nvSpPr>
-          <p:cNvPr id="205" name="Google Shape;205;p31"/>
-          <p:cNvSpPr txBox="1"/>
-          <p:nvPr>
-            <p:ph idx="1" type="subTitle"/>
-          </p:nvPr>
-        </p:nvSpPr>
-        <p:spPr>
-          <a:xfrm>
-            <a:off x="0" y="2569475"/>
-            <a:ext cx="9144000" cy="2574000"/>
-          </a:xfrm>
-          <a:prstGeom prst="rect">
-            <a:avLst/>
-          </a:prstGeom>
-        </p:spPr>
-        <p:txBody>
-          <a:bodyPr anchorCtr="0" anchor="t" bIns="91425" lIns="91425" spcFirstLastPara="1" rIns="91425" wrap="square" tIns="274300">
-            <a:noAutofit/>
-          </a:bodyPr>
-          <a:lstStyle/>
-          <a:p>
-            <a:pPr indent="0" lvl="0" marL="0" rtl="0" algn="ctr">
-              <a:lnSpc>
-                <a:spcPct val="150000"/>
-              </a:lnSpc>
-              <a:spcBef>
-                <a:spcPts val="0"/>
-              </a:spcBef>
-              <a:spcAft>
-                <a:spcPts val="0"/>
-              </a:spcAft>
-              <a:buNone/>
-            </a:pPr>
-            <a:r>
-              <a:rPr lang="en" u="sng">
-                <a:solidFill>
-                  <a:schemeClr val="hlink"/>
-                </a:solidFill>
-                <a:hlinkClick r:id="rId3"/>
-              </a:rPr>
-              <a:t>dirk.riehle@fau.de</a:t>
-            </a:r>
-            <a:r>
-              <a:rPr lang="en"/>
-              <a:t> </a:t>
-            </a:r>
-            <a:r>
-              <a:rPr lang="en" sz="2400"/>
-              <a:t>–</a:t>
-            </a:r>
-            <a:r>
-              <a:rPr lang="en"/>
-              <a:t> </a:t>
-            </a:r>
-            <a:r>
-              <a:rPr lang="en" u="sng">
-                <a:solidFill>
-                  <a:schemeClr val="hlink"/>
-                </a:solidFill>
-                <a:hlinkClick r:id="rId4"/>
-              </a:rPr>
-              <a:t>https://oss.cs.fau.de</a:t>
-            </a:r>
-            <a:endParaRPr/>
-          </a:p>
-          <a:p>
-            <a:pPr indent="0" lvl="0" marL="0" rtl="0" algn="ctr">
-              <a:lnSpc>
-                <a:spcPct val="150000"/>
-              </a:lnSpc>
-              <a:spcBef>
-                <a:spcPts val="0"/>
-              </a:spcBef>
-              <a:spcAft>
-                <a:spcPts val="0"/>
-              </a:spcAft>
-              <a:buNone/>
-            </a:pPr>
-            <a:r>
-              <a:rPr lang="en" sz="2400" u="sng">
-                <a:solidFill>
-                  <a:schemeClr val="hlink"/>
-                </a:solidFill>
-                <a:hlinkClick r:id="rId5"/>
-              </a:rPr>
-              <a:t>dirk@riehle.org</a:t>
-            </a:r>
-            <a:r>
-              <a:rPr lang="en" sz="2400"/>
-              <a:t> – </a:t>
-            </a:r>
-            <a:r>
-              <a:rPr lang="en" sz="2400" u="sng">
-                <a:solidFill>
-                  <a:schemeClr val="hlink"/>
-                </a:solidFill>
-                <a:hlinkClick r:id="rId6"/>
-              </a:rPr>
-              <a:t>https://dirkriehle.com</a:t>
-            </a:r>
-            <a:r>
-              <a:rPr lang="en" sz="2400"/>
-              <a:t> – </a:t>
-            </a:r>
-            <a:r>
-              <a:rPr lang="en" sz="2400" u="sng">
-                <a:solidFill>
-                  <a:schemeClr val="hlink"/>
-                </a:solidFill>
-                <a:hlinkClick r:id="rId7"/>
-              </a:rPr>
-              <a:t>@dirkriehle</a:t>
-            </a:r>
-            <a:endParaRPr sz="2400"/>
-          </a:p>
-        </p:txBody>
-      </p:sp>
-    </p:spTree>
-  </p:cSld>
-  <p:clrMapOvr>
-    <a:masterClrMapping/>
-  </p:clrMapOvr>
-</p:sld>
-</file>
-
-<file path=ppt/slides/slide25.xml><?xml version="1.0" encoding="utf-8"?>
-<p:sld xmlns:a="http://schemas.openxmlformats.org/drawingml/2006/main" xmlns:r="http://schemas.openxmlformats.org/officeDocument/2006/relationships" xmlns:mc="http://schemas.openxmlformats.org/markup-compatibility/2006" xmlns:mv="urn:schemas-microsoft-com:mac:vml" xmlns:p="http://schemas.openxmlformats.org/presentationml/2006/main" xmlns:c="http://schemas.openxmlformats.org/drawingml/2006/chart" xmlns:dgm="http://schemas.openxmlformats.org/drawingml/2006/diagram" xmlns:o="urn:schemas-microsoft-com:office:office" xmlns:v="urn:schemas-microsoft-com:vml" xmlns:pvml="urn:schemas-microsoft-com:office:powerpoint" xmlns:com="http://schemas.openxmlformats.org/drawingml/2006/compatibility" xmlns:p14="http://schemas.microsoft.com/office/powerpoint/2010/main" xmlns:p15="http://schemas.microsoft.com/office/powerpoint/2012/main" xmlns:ahyp="http://schemas.microsoft.com/office/drawing/2018/hyperlinkcolor">
-  <p:cSld>
-    <p:spTree>
-      <p:nvGrpSpPr>
-        <p:cNvPr id="209" name="Shape 209"/>
-        <p:cNvGrpSpPr/>
-        <p:nvPr/>
-      </p:nvGrpSpPr>
-      <p:grpSpPr>
-        <a:xfrm>
-          <a:off x="0" y="0"/>
-          <a:ext cx="0" cy="0"/>
-          <a:chOff x="0" y="0"/>
-          <a:chExt cx="0" cy="0"/>
-        </a:xfrm>
-      </p:grpSpPr>
-      <p:sp>
-        <p:nvSpPr>
-          <p:cNvPr id="210" name="Google Shape;210;p32"/>
-          <p:cNvSpPr txBox="1"/>
-          <p:nvPr>
-            <p:ph type="title"/>
-          </p:nvPr>
-        </p:nvSpPr>
-        <p:spPr>
-          <a:xfrm>
-            <a:off x="0" y="0"/>
-            <a:ext cx="9144000" cy="685800"/>
-          </a:xfrm>
-          <a:prstGeom prst="rect">
-            <a:avLst/>
-          </a:prstGeom>
-        </p:spPr>
-        <p:txBody>
-          <a:bodyPr anchorCtr="0" anchor="ctr" bIns="91425" lIns="274300" spcFirstLastPara="1" rIns="91425" wrap="square" tIns="91425">
-            <a:noAutofit/>
-          </a:bodyPr>
-          <a:lstStyle/>
-          <a:p>
-            <a:pPr indent="0" lvl="0" marL="0" rtl="0" algn="l">
-              <a:spcBef>
-                <a:spcPts val="0"/>
-              </a:spcBef>
-              <a:spcAft>
-                <a:spcPts val="0"/>
-              </a:spcAft>
-              <a:buNone/>
-            </a:pPr>
-            <a:r>
-              <a:rPr lang="en"/>
-              <a:t>Legal Notices</a:t>
-            </a:r>
-            <a:endParaRPr/>
-          </a:p>
-        </p:txBody>
-      </p:sp>
-      <p:sp>
-        <p:nvSpPr>
-          <p:cNvPr id="211" name="Google Shape;211;p32"/>
-          <p:cNvSpPr txBox="1"/>
-          <p:nvPr>
-            <p:ph idx="12" type="sldNum"/>
-          </p:nvPr>
-        </p:nvSpPr>
-        <p:spPr>
-          <a:xfrm>
-            <a:off x="7315209" y="4229101"/>
-            <a:ext cx="1828800" cy="914400"/>
-          </a:xfrm>
-          <a:prstGeom prst="rect">
-            <a:avLst/>
-          </a:prstGeom>
-        </p:spPr>
-        <p:txBody>
-          <a:bodyPr anchorCtr="0" anchor="b" bIns="91425" lIns="91425" spcFirstLastPara="1" rIns="91425" wrap="square" tIns="91425">
-            <a:noAutofit/>
-          </a:bodyPr>
-          <a:lstStyle/>
-          <a:p>
-            <a:pPr indent="0" lvl="0" marL="0" rtl="0" algn="r">
-              <a:spcBef>
-                <a:spcPts val="0"/>
-              </a:spcBef>
-              <a:spcAft>
-                <a:spcPts val="0"/>
-              </a:spcAft>
-              <a:buNone/>
-            </a:pPr>
-            <a:fld id="{00000000-1234-1234-1234-123412341234}" type="slidenum">
-              <a:rPr lang="en"/>
-              <a:t>‹#›</a:t>
-            </a:fld>
-            <a:endParaRPr/>
-          </a:p>
-          <a:p>
-            <a:pPr indent="0" lvl="0" marL="0" rtl="0" algn="r">
-              <a:spcBef>
-                <a:spcPts val="0"/>
-              </a:spcBef>
-              <a:spcAft>
-                <a:spcPts val="0"/>
-              </a:spcAft>
-              <a:buNone/>
-            </a:pPr>
-            <a:r>
-              <a:rPr b="0" lang="en" sz="900" u="sng">
-                <a:solidFill>
-                  <a:schemeClr val="hlink"/>
-                </a:solidFill>
-                <a:hlinkClick r:id="rId3"/>
-              </a:rPr>
-              <a:t>https://profriehle.com</a:t>
-            </a:r>
-            <a:r>
-              <a:rPr b="0" lang="en" sz="900">
-                <a:solidFill>
-                  <a:schemeClr val="dk2"/>
-                </a:solidFill>
-              </a:rPr>
-              <a:t> </a:t>
-            </a:r>
-            <a:endParaRPr b="0" sz="900">
-              <a:solidFill>
-                <a:schemeClr val="dk2"/>
-              </a:solidFill>
-            </a:endParaRPr>
-          </a:p>
-        </p:txBody>
-      </p:sp>
-      <p:sp>
-        <p:nvSpPr>
-          <p:cNvPr id="212" name="Google Shape;212;p32"/>
-          <p:cNvSpPr txBox="1"/>
-          <p:nvPr>
-            <p:ph idx="1" type="body"/>
-          </p:nvPr>
-        </p:nvSpPr>
-        <p:spPr>
-          <a:xfrm>
-            <a:off x="274320" y="914400"/>
-            <a:ext cx="8595300" cy="4114800"/>
-          </a:xfrm>
-          <a:prstGeom prst="rect">
-            <a:avLst/>
-          </a:prstGeom>
-        </p:spPr>
-        <p:txBody>
-          <a:bodyPr anchorCtr="0" anchor="t" bIns="0" lIns="0" spcFirstLastPara="1" rIns="0" wrap="square" tIns="0">
-            <a:noAutofit/>
-          </a:bodyPr>
-          <a:lstStyle/>
-          <a:p>
-            <a:pPr indent="0" lvl="0" marL="0" rtl="0" algn="l">
-              <a:spcBef>
-                <a:spcPts val="0"/>
-              </a:spcBef>
-              <a:spcAft>
                 <a:spcPts val="0"/>
               </a:spcAft>
               <a:buNone/>
@@ -12754,7 +12367,7 @@
             </a:pPr>
             <a:r>
               <a:rPr lang="en"/>
-              <a:t>© 2012, 2023, 2024 Dirk Riehle, some rights reserved</a:t>
+              <a:t>© 2025 Dirk Riehle, some rights reserved</a:t>
             </a:r>
             <a:endParaRPr/>
           </a:p>
@@ -14189,7 +13802,7 @@
             <a:tbl>
               <a:tblPr>
                 <a:noFill/>
-                <a:tableStyleId>{BDD3B64A-7FFF-4E8F-87F6-037DE44E73C1}</a:tableStyleId>
+                <a:tableStyleId>{96A21E03-E013-4868-B2C2-C3E1341E02A3}</a:tableStyleId>
               </a:tblPr>
               <a:tblGrid>
                 <a:gridCol w="1432575"/>
@@ -14279,14 +13892,14 @@
                         <a:buNone/>
                       </a:pPr>
                       <a:r>
-                        <a:rPr b="1" lang="en" sz="1800">
+                        <a:rPr b="1" lang="en">
                           <a:solidFill>
                             <a:schemeClr val="lt1"/>
                           </a:solidFill>
                         </a:rPr>
                         <a:t>Courses (Lehrveranstaltungen)</a:t>
                       </a:r>
-                      <a:endParaRPr b="1" sz="1800">
+                      <a:endParaRPr b="1">
                         <a:solidFill>
                           <a:schemeClr val="lt1"/>
                         </a:solidFill>
@@ -14711,14 +14324,14 @@
                         <a:buNone/>
                       </a:pPr>
                       <a:r>
-                        <a:rPr b="1" lang="en" sz="1800">
+                        <a:rPr b="1" lang="en">
                           <a:solidFill>
                             <a:schemeClr val="lt1"/>
                           </a:solidFill>
                         </a:rPr>
                         <a:t>Modules</a:t>
                       </a:r>
-                      <a:endParaRPr b="1" sz="1800">
+                      <a:endParaRPr b="1">
                         <a:solidFill>
                           <a:schemeClr val="lt1"/>
                         </a:solidFill>
@@ -16199,7 +15812,7 @@
             <a:tbl>
               <a:tblPr>
                 <a:noFill/>
-                <a:tableStyleId>{BDD3B64A-7FFF-4E8F-87F6-037DE44E73C1}</a:tableStyleId>
+                <a:tableStyleId>{96A21E03-E013-4868-B2C2-C3E1341E02A3}</a:tableStyleId>
               </a:tblPr>
               <a:tblGrid>
                 <a:gridCol w="1432550"/>
@@ -16343,14 +15956,14 @@
                         <a:buNone/>
                       </a:pPr>
                       <a:r>
-                        <a:rPr b="1" lang="en" sz="1800">
+                        <a:rPr b="1" lang="en">
                           <a:solidFill>
                             <a:schemeClr val="lt1"/>
                           </a:solidFill>
                         </a:rPr>
                         <a:t>University</a:t>
                       </a:r>
-                      <a:endParaRPr b="1" sz="1800">
+                      <a:endParaRPr b="1">
                         <a:solidFill>
                           <a:schemeClr val="lt1"/>
                         </a:solidFill>
@@ -16542,7 +16155,15 @@
                             <a:schemeClr val="lt1"/>
                           </a:solidFill>
                         </a:rPr>
-                        <a:t>Univ. Erlangen</a:t>
+                        <a:t>FAU</a:t>
+                      </a:r>
+                      <a:r>
+                        <a:rPr b="1" lang="en">
+                          <a:solidFill>
+                            <a:schemeClr val="lt1"/>
+                          </a:solidFill>
+                        </a:rPr>
+                        <a:t> Erlangen</a:t>
                       </a:r>
                       <a:endParaRPr b="1">
                         <a:solidFill>
@@ -16800,14 +16421,14 @@
                         <a:buNone/>
                       </a:pPr>
                       <a:r>
-                        <a:rPr b="1" lang="en" sz="1800">
+                        <a:rPr b="1" lang="en">
                           <a:solidFill>
                             <a:schemeClr val="lt1"/>
                           </a:solidFill>
                         </a:rPr>
                         <a:t>Modules</a:t>
                       </a:r>
-                      <a:endParaRPr b="1" sz="1800">
+                      <a:endParaRPr b="1">
                         <a:solidFill>
                           <a:schemeClr val="lt1"/>
                         </a:solidFill>
@@ -18178,7 +17799,7 @@
         </p:nvSpPr>
         <p:spPr>
           <a:xfrm>
-            <a:off x="7315209" y="4229101"/>
+            <a:off x="7315209" y="4233676"/>
             <a:ext cx="1828800" cy="914400"/>
           </a:xfrm>
           <a:prstGeom prst="rect">

</xml_diff>